<commit_message>
chore: refresh pptx with structured sections
Co-authored-by: VinhSquid <239130662+VinhSquid@users.noreply.github.com>
</commit_message>
<xml_diff>
--- a/slideshow.pptx
+++ b/slideshow.pptx
@@ -11,6 +11,8 @@
     <p:sldId id="259" r:id="rId10"/>
     <p:sldId id="260" r:id="rId11"/>
     <p:sldId id="261" r:id="rId12"/>
+    <p:sldId id="262" r:id="rId13"/>
+    <p:sldId id="263" r:id="rId14"/>
   </p:sldIdLst>
   <p:sldSz cx="9144000" cy="6858000" type="screen4x3"/>
   <p:notesSz cx="6858000" cy="9144000"/>
@@ -3108,8 +3110,14 @@
           <a:bodyPr/>
           <a:lstStyle/>
           <a:p>
-            <a:r>
-              <a:t>Sharing Session: Recent Projects</a:t>
+            <a:pPr/>
+            <a:r>
+              <a:rPr sz="2200">
+                <a:solidFill>
+                  <a:srgbClr val="222222"/>
+                </a:solidFill>
+              </a:rPr>
+              <a:t>Sharing Session</a:t>
             </a:r>
           </a:p>
         </p:txBody>
@@ -3129,8 +3137,14 @@
           <a:bodyPr/>
           <a:lstStyle/>
           <a:p>
-            <a:r>
-              <a:t>Link Plus | Notify Vue 3 Migration | FrameworkLegacy NuGet</a:t>
+            <a:pPr/>
+            <a:r>
+              <a:rPr sz="2200">
+                <a:solidFill>
+                  <a:srgbClr val="222222"/>
+                </a:solidFill>
+              </a:rPr>
+              <a:t>Vue 3 Migration (Link Plus, Notify) | FrameworkLegacy NuGet</a:t>
             </a:r>
           </a:p>
         </p:txBody>
@@ -3168,7 +3182,13 @@
           <a:bodyPr/>
           <a:lstStyle/>
           <a:p>
-            <a:r>
+            <a:pPr/>
+            <a:r>
+              <a:rPr sz="2200">
+                <a:solidFill>
+                  <a:srgbClr val="222222"/>
+                </a:solidFill>
+              </a:rPr>
               <a:t>Agenda</a:t>
             </a:r>
           </a:p>
@@ -3191,31 +3211,56 @@
           <a:p>
             <a:pPr/>
             <a:r>
-              <a:t>Context &amp; goals</a:t>
+              <a:rPr sz="2200">
+                <a:solidFill>
+                  <a:srgbClr val="222222"/>
+                </a:solidFill>
+              </a:rPr>
+              <a:t>Vue 3 Migration</a:t>
+            </a:r>
+          </a:p>
+          <a:p>
+            <a:pPr lvl="1"/>
+            <a:r>
+              <a:rPr sz="2000">
+                <a:solidFill>
+                  <a:srgbClr val="222222"/>
+                </a:solidFill>
+              </a:rPr>
+              <a:t>  - Link Plus</a:t>
+            </a:r>
+          </a:p>
+          <a:p>
+            <a:pPr lvl="1"/>
+            <a:r>
+              <a:rPr sz="2000">
+                <a:solidFill>
+                  <a:srgbClr val="222222"/>
+                </a:solidFill>
+              </a:rPr>
+              <a:t>  - Notify</a:t>
             </a:r>
           </a:p>
           <a:p>
             <a:pPr/>
             <a:r>
-              <a:t>Link Plus (class-based)</a:t>
+              <a:rPr sz="2200">
+                <a:solidFill>
+                  <a:srgbClr val="222222"/>
+                </a:solidFill>
+              </a:rPr>
+              <a:t>FrameworkLegacy NuGet project</a:t>
             </a:r>
           </a:p>
           <a:p>
             <a:pPr/>
             <a:r>
-              <a:t>Notify Vue 3 migration (Composition API)</a:t>
-            </a:r>
-          </a:p>
-          <a:p>
-            <a:pPr/>
-            <a:r>
-              <a:t>FrameworkLegacy NuGet project</a:t>
-            </a:r>
-          </a:p>
-          <a:p>
-            <a:pPr/>
-            <a:r>
-              <a:t>Lessons learned &amp; next steps</a:t>
+              <a:rPr sz="2200">
+                <a:solidFill>
+                  <a:srgbClr val="222222"/>
+                </a:solidFill>
+              </a:rPr>
+              <a:t>Lessons &amp; next steps</a:t>
             </a:r>
           </a:p>
         </p:txBody>
@@ -3253,54 +3298,41 @@
           <a:bodyPr/>
           <a:lstStyle/>
           <a:p>
-            <a:r>
-              <a:t>Link Plus (Class-Based)</a:t>
-            </a:r>
-          </a:p>
-        </p:txBody>
-      </p:sp>
-      <p:sp>
-        <p:nvSpPr>
-          <p:cNvPr id="3" name="Content Placeholder 2"/>
-          <p:cNvSpPr>
-            <a:spLocks noGrp="1"/>
-          </p:cNvSpPr>
-          <p:nvPr>
-            <p:ph idx="1"/>
-          </p:nvPr>
-        </p:nvSpPr>
-        <p:spPr/>
-        <p:txBody>
-          <a:bodyPr/>
-          <a:lstStyle/>
-          <a:p>
             <a:pPr/>
             <a:r>
-              <a:t>Goal: Integrate partner links with unified tracking and reporting</a:t>
-            </a:r>
-          </a:p>
+              <a:rPr sz="2200">
+                <a:solidFill>
+                  <a:srgbClr val="222222"/>
+                </a:solidFill>
+              </a:rPr>
+              <a:t>Vue 3 Migration</a:t>
+            </a:r>
+          </a:p>
+        </p:txBody>
+      </p:sp>
+      <p:sp>
+        <p:nvSpPr>
+          <p:cNvPr id="3" name="Text Placeholder 2"/>
+          <p:cNvSpPr>
+            <a:spLocks noGrp="1"/>
+          </p:cNvSpPr>
+          <p:nvPr>
+            <p:ph type="body" idx="1"/>
+          </p:nvPr>
+        </p:nvSpPr>
+        <p:spPr/>
+        <p:txBody>
+          <a:bodyPr/>
+          <a:lstStyle/>
           <a:p>
             <a:pPr/>
             <a:r>
-              <a:t>Stack: Vue 2, TypeScript, class-based components, REST APIs</a:t>
-            </a:r>
-          </a:p>
-          <a:p>
-            <a:pPr/>
-            <a:r>
-              <a:t>Role: Designed data models, built link management UI, tracking hooks</a:t>
-            </a:r>
-          </a:p>
-          <a:p>
-            <a:pPr/>
-            <a:r>
-              <a:t>Highlights: Faster onboarding, audit logs, reduced setup time</a:t>
-            </a:r>
-          </a:p>
-          <a:p>
-            <a:pPr/>
-            <a:r>
-              <a:t>Challenges: Backward compatibility via feature flags/A-B rollout</a:t>
+              <a:rPr sz="2200">
+                <a:solidFill>
+                  <a:srgbClr val="222222"/>
+                </a:solidFill>
+              </a:rPr>
+              <a:t>Link Plus &amp; Notify modernization</a:t>
             </a:r>
           </a:p>
         </p:txBody>
@@ -3338,8 +3370,14 @@
           <a:bodyPr/>
           <a:lstStyle/>
           <a:p>
-            <a:r>
-              <a:t>Notify Migration to Vue 3 (Composition API)</a:t>
+            <a:pPr/>
+            <a:r>
+              <a:rPr sz="2200">
+                <a:solidFill>
+                  <a:srgbClr val="222222"/>
+                </a:solidFill>
+              </a:rPr>
+              <a:t>Link Plus</a:t>
             </a:r>
           </a:p>
         </p:txBody>
@@ -3361,31 +3399,56 @@
           <a:p>
             <a:pPr/>
             <a:r>
-              <a:t>Goal: Modernize notification center for performance/maintainability</a:t>
+              <a:rPr sz="2200">
+                <a:solidFill>
+                  <a:srgbClr val="222222"/>
+                </a:solidFill>
+              </a:rPr>
+              <a:t>Goal: Integrate partner links with unified tracking/reporting</a:t>
             </a:r>
           </a:p>
           <a:p>
             <a:pPr/>
             <a:r>
-              <a:t>Stack: Vue 3, Composition API, TypeScript, Pinia, Vite</a:t>
+              <a:rPr sz="2200">
+                <a:solidFill>
+                  <a:srgbClr val="222222"/>
+                </a:solidFill>
+              </a:rPr>
+              <a:t>Approach: Vue 2 class-based components; feature flags for safe rollout</a:t>
             </a:r>
           </a:p>
           <a:p>
             <a:pPr/>
             <a:r>
-              <a:t>Role: Led migration, refactored widget, reusable composables</a:t>
+              <a:rPr sz="2200">
+                <a:solidFill>
+                  <a:srgbClr val="222222"/>
+                </a:solidFill>
+              </a:rPr>
+              <a:t>Role: Data model design, link management UI, tracking hooks</a:t>
             </a:r>
           </a:p>
           <a:p>
             <a:pPr/>
             <a:r>
-              <a:t>Highlights: Smaller bundle, faster renders, accessibility tweaks</a:t>
+              <a:rPr sz="2200">
+                <a:solidFill>
+                  <a:srgbClr val="222222"/>
+                </a:solidFill>
+              </a:rPr>
+              <a:t>Highlights: Faster onboarding, audit logs, reduced setup time</a:t>
             </a:r>
           </a:p>
           <a:p>
             <a:pPr/>
             <a:r>
-              <a:t>Challenges: Legacy Vue 2 plugins bridged with compat build &amp; gradual conversion</a:t>
+              <a:rPr sz="2200">
+                <a:solidFill>
+                  <a:srgbClr val="222222"/>
+                </a:solidFill>
+              </a:rPr>
+              <a:t>Risks/mitigation: Backward compatibility via A/B and migration guides</a:t>
             </a:r>
           </a:p>
         </p:txBody>
@@ -3423,8 +3486,14 @@
           <a:bodyPr/>
           <a:lstStyle/>
           <a:p>
-            <a:r>
-              <a:t>FrameworkLegacy (NuGet)</a:t>
+            <a:pPr/>
+            <a:r>
+              <a:rPr sz="2200">
+                <a:solidFill>
+                  <a:srgbClr val="222222"/>
+                </a:solidFill>
+              </a:rPr>
+              <a:t>Notify</a:t>
             </a:r>
           </a:p>
         </p:txBody>
@@ -3446,31 +3515,56 @@
           <a:p>
             <a:pPr/>
             <a:r>
-              <a:t>Goal: Shared helpers for legacy .NET apps</a:t>
+              <a:rPr sz="2200">
+                <a:solidFill>
+                  <a:srgbClr val="222222"/>
+                </a:solidFill>
+              </a:rPr>
+              <a:t>Goal: Modernize notification center for performance/maintainability</a:t>
             </a:r>
           </a:p>
           <a:p>
             <a:pPr/>
             <a:r>
-              <a:t>Stack: .NET Framework, NuGet packaging, CI publishing</a:t>
+              <a:rPr sz="2200">
+                <a:solidFill>
+                  <a:srgbClr val="222222"/>
+                </a:solidFill>
+              </a:rPr>
+              <a:t>Approach: Vue 3 + Composition API, Pinia, Vite; reusable composables</a:t>
             </a:r>
           </a:p>
           <a:p>
             <a:pPr/>
             <a:r>
-              <a:t>Role: Authored utilities, logging &amp; config helpers, automated release</a:t>
+              <a:rPr sz="2200">
+                <a:solidFill>
+                  <a:srgbClr val="222222"/>
+                </a:solidFill>
+              </a:rPr>
+              <a:t>Role: Led migration plan, refactored widget, bridged legacy plugins</a:t>
             </a:r>
           </a:p>
           <a:p>
             <a:pPr/>
             <a:r>
-              <a:t>Highlights: Less duplicate code, standardized logging, CI versioning</a:t>
+              <a:rPr sz="2200">
+                <a:solidFill>
+                  <a:srgbClr val="222222"/>
+                </a:solidFill>
+              </a:rPr>
+              <a:t>Highlights: Smaller bundle, faster render, accessibility improvements</a:t>
             </a:r>
           </a:p>
           <a:p>
             <a:pPr/>
             <a:r>
-              <a:t>Challenges: Versioning with consumers via semver + deprecation notes</a:t>
+              <a:rPr sz="2200">
+                <a:solidFill>
+                  <a:srgbClr val="222222"/>
+                </a:solidFill>
+              </a:rPr>
+              <a:t>Risks/mitigation: Compat build during transition; gradual module conversion</a:t>
             </a:r>
           </a:p>
         </p:txBody>
@@ -3508,7 +3602,201 @@
           <a:bodyPr/>
           <a:lstStyle/>
           <a:p>
-            <a:r>
+            <a:pPr/>
+            <a:r>
+              <a:rPr sz="2200">
+                <a:solidFill>
+                  <a:srgbClr val="222222"/>
+                </a:solidFill>
+              </a:rPr>
+              <a:t>FrameworkLegacy NuGet</a:t>
+            </a:r>
+          </a:p>
+        </p:txBody>
+      </p:sp>
+      <p:sp>
+        <p:nvSpPr>
+          <p:cNvPr id="3" name="Text Placeholder 2"/>
+          <p:cNvSpPr>
+            <a:spLocks noGrp="1"/>
+          </p:cNvSpPr>
+          <p:nvPr>
+            <p:ph type="body" idx="1"/>
+          </p:nvPr>
+        </p:nvSpPr>
+        <p:spPr/>
+        <p:txBody>
+          <a:bodyPr/>
+          <a:lstStyle/>
+          <a:p>
+            <a:pPr/>
+            <a:r>
+              <a:rPr sz="2200">
+                <a:solidFill>
+                  <a:srgbClr val="222222"/>
+                </a:solidFill>
+              </a:rPr>
+              <a:t>Shared helpers split into NuGet packages</a:t>
+            </a:r>
+          </a:p>
+        </p:txBody>
+      </p:sp>
+    </p:spTree>
+  </p:cSld>
+  <p:clrMapOvr>
+    <a:masterClrMapping/>
+  </p:clrMapOvr>
+</p:sld>
+</file>
+
+<file path=ppt/slides/slide7.xml><?xml version="1.0" encoding="utf-8"?>
+<p:sld xmlns:a="http://schemas.openxmlformats.org/drawingml/2006/main" xmlns:p="http://schemas.openxmlformats.org/presentationml/2006/main" xmlns:r="http://schemas.openxmlformats.org/officeDocument/2006/relationships">
+  <p:cSld>
+    <p:spTree>
+      <p:nvGrpSpPr>
+        <p:cNvPr id="1" name=""/>
+        <p:cNvGrpSpPr/>
+        <p:nvPr/>
+      </p:nvGrpSpPr>
+      <p:grpSpPr/>
+      <p:sp>
+        <p:nvSpPr>
+          <p:cNvPr id="2" name="Title 1"/>
+          <p:cNvSpPr>
+            <a:spLocks noGrp="1"/>
+          </p:cNvSpPr>
+          <p:nvPr>
+            <p:ph type="title"/>
+          </p:nvPr>
+        </p:nvSpPr>
+        <p:spPr/>
+        <p:txBody>
+          <a:bodyPr/>
+          <a:lstStyle/>
+          <a:p>
+            <a:pPr/>
+            <a:r>
+              <a:rPr sz="2200">
+                <a:solidFill>
+                  <a:srgbClr val="222222"/>
+                </a:solidFill>
+              </a:rPr>
+              <a:t>FrameworkLegacy</a:t>
+            </a:r>
+          </a:p>
+        </p:txBody>
+      </p:sp>
+      <p:sp>
+        <p:nvSpPr>
+          <p:cNvPr id="3" name="Content Placeholder 2"/>
+          <p:cNvSpPr>
+            <a:spLocks noGrp="1"/>
+          </p:cNvSpPr>
+          <p:nvPr>
+            <p:ph idx="1"/>
+          </p:nvPr>
+        </p:nvSpPr>
+        <p:spPr/>
+        <p:txBody>
+          <a:bodyPr/>
+          <a:lstStyle/>
+          <a:p>
+            <a:pPr/>
+            <a:r>
+              <a:rPr sz="2200">
+                <a:solidFill>
+                  <a:srgbClr val="222222"/>
+                </a:solidFill>
+              </a:rPr>
+              <a:t>Goal: Extract shared projects into NuGet for reuse</a:t>
+            </a:r>
+          </a:p>
+          <a:p>
+            <a:pPr/>
+            <a:r>
+              <a:rPr sz="2200">
+                <a:solidFill>
+                  <a:srgbClr val="222222"/>
+                </a:solidFill>
+              </a:rPr>
+              <a:t>Approach: .NET Framework utilities packaged; CI-driven versioning</a:t>
+            </a:r>
+          </a:p>
+          <a:p>
+            <a:pPr/>
+            <a:r>
+              <a:rPr sz="2200">
+                <a:solidFill>
+                  <a:srgbClr val="222222"/>
+                </a:solidFill>
+              </a:rPr>
+              <a:t>Role: Authored logging/config helpers; automated publishing</a:t>
+            </a:r>
+          </a:p>
+          <a:p>
+            <a:pPr/>
+            <a:r>
+              <a:rPr sz="2200">
+                <a:solidFill>
+                  <a:srgbClr val="222222"/>
+                </a:solidFill>
+              </a:rPr>
+              <a:t>Highlights: Less duplicate code; standardized logging; easy consumer updates</a:t>
+            </a:r>
+          </a:p>
+          <a:p>
+            <a:pPr/>
+            <a:r>
+              <a:rPr sz="2200">
+                <a:solidFill>
+                  <a:srgbClr val="222222"/>
+                </a:solidFill>
+              </a:rPr>
+              <a:t>Integration: Downstream apps add NuGet package instead of direct project refs</a:t>
+            </a:r>
+          </a:p>
+        </p:txBody>
+      </p:sp>
+    </p:spTree>
+  </p:cSld>
+  <p:clrMapOvr>
+    <a:masterClrMapping/>
+  </p:clrMapOvr>
+</p:sld>
+</file>
+
+<file path=ppt/slides/slide8.xml><?xml version="1.0" encoding="utf-8"?>
+<p:sld xmlns:a="http://schemas.openxmlformats.org/drawingml/2006/main" xmlns:p="http://schemas.openxmlformats.org/presentationml/2006/main" xmlns:r="http://schemas.openxmlformats.org/officeDocument/2006/relationships">
+  <p:cSld>
+    <p:spTree>
+      <p:nvGrpSpPr>
+        <p:cNvPr id="1" name=""/>
+        <p:cNvGrpSpPr/>
+        <p:nvPr/>
+      </p:nvGrpSpPr>
+      <p:grpSpPr/>
+      <p:sp>
+        <p:nvSpPr>
+          <p:cNvPr id="2" name="Title 1"/>
+          <p:cNvSpPr>
+            <a:spLocks noGrp="1"/>
+          </p:cNvSpPr>
+          <p:nvPr>
+            <p:ph type="title"/>
+          </p:nvPr>
+        </p:nvSpPr>
+        <p:spPr/>
+        <p:txBody>
+          <a:bodyPr/>
+          <a:lstStyle/>
+          <a:p>
+            <a:pPr/>
+            <a:r>
+              <a:rPr sz="2200">
+                <a:solidFill>
+                  <a:srgbClr val="222222"/>
+                </a:solidFill>
+              </a:rPr>
               <a:t>Lessons &amp; Next Steps</a:t>
             </a:r>
           </a:p>
@@ -3531,24 +3819,44 @@
           <a:p>
             <a:pPr/>
             <a:r>
+              <a:rPr sz="2200">
+                <a:solidFill>
+                  <a:srgbClr val="222222"/>
+                </a:solidFill>
+              </a:rPr>
               <a:t>Use feature flags/compat layers for migrations</a:t>
             </a:r>
           </a:p>
           <a:p>
             <a:pPr/>
             <a:r>
-              <a:t>Favor composables/hooks for reuse &amp; tests</a:t>
+              <a:rPr sz="2200">
+                <a:solidFill>
+                  <a:srgbClr val="222222"/>
+                </a:solidFill>
+              </a:rPr>
+              <a:t>Favor composables/hooks for reuse and testability</a:t>
             </a:r>
           </a:p>
           <a:p>
             <a:pPr/>
             <a:r>
-              <a:t>Automate packaging/publishing; add metrics to Link Plus flows</a:t>
+              <a:rPr sz="2200">
+                <a:solidFill>
+                  <a:srgbClr val="222222"/>
+                </a:solidFill>
+              </a:rPr>
+              <a:t>Automate packaging &amp; publishing; track metrics on Link Plus flows</a:t>
             </a:r>
           </a:p>
           <a:p>
             <a:pPr/>
             <a:r>
+              <a:rPr sz="2200">
+                <a:solidFill>
+                  <a:srgbClr val="222222"/>
+                </a:solidFill>
+              </a:rPr>
               <a:t>Expand Vue 3 patterns; publish FrameworkLegacy roadmap</a:t>
             </a:r>
           </a:p>

</xml_diff>